<commit_message>
fix: DCS deck slides 2 and 7 legibility
- Slide 2: Added large white '17%' stat callout in the empty navy panel
- Slide 7: Reduced font sizes (1100-1400pt), removed blank spacer
  paragraphs, trimmed bullet text to fit within card boundaries
  without overflowing the DCS logo
</commit_message>
<xml_diff>
--- a/DCS-CDH-Bridge-GTM-DCS.pptx
+++ b/DCS-CDH-Bridge-GTM-DCS.pptx
@@ -30384,6 +30384,79 @@
           </a:p>
         </p:txBody>
       </p:sp>
+      <p:sp>
+        <p:nvSpPr>
+          <p:cNvPr id="10" name="NavyCallout"/>
+          <p:cNvSpPr/>
+          <p:nvPr/>
+        </p:nvSpPr>
+        <p:spPr>
+          <a:xfrm>
+            <a:off x="6766800" y="1371600"/>
+            <a:ext cx="4800600" cy="4114800"/>
+          </a:xfrm>
+          <a:prstGeom prst="rect">
+            <a:avLst/>
+          </a:prstGeom>
+          <a:noFill/>
+        </p:spPr>
+        <p:txBody>
+          <a:bodyPr wrap="square">
+            <a:normAutofit/>
+          </a:bodyPr>
+          <a:lstStyle/>
+          <a:p>
+            <a:r>
+              <a:rPr lang="en-GB" sz="8000" b="1">
+                <a:solidFill>
+                  <a:srgbClr val="FFFFFF"/>
+                </a:solidFill>
+              </a:rPr>
+              <a:t>17%</a:t>
+            </a:r>
+          </a:p>
+          <a:p>
+            <a:r>
+              <a:rPr lang="en-GB" sz="1600">
+                <a:solidFill>
+                  <a:srgbClr val="FFFFFF"/>
+                </a:solidFill>
+              </a:rPr>
+              <a:t>of Pega CDH deployments</a:t>
+            </a:r>
+          </a:p>
+          <a:p>
+            <a:r>
+              <a:rPr lang="en-GB" sz="1600">
+                <a:solidFill>
+                  <a:srgbClr val="FFFFFF"/>
+                </a:solidFill>
+              </a:rPr>
+              <a:t>achieve high real-time</a:t>
+            </a:r>
+          </a:p>
+          <a:p>
+            <a:r>
+              <a:rPr lang="en-GB" sz="1600">
+                <a:solidFill>
+                  <a:srgbClr val="FFFFFF"/>
+                </a:solidFill>
+              </a:rPr>
+              <a:t>personalisation today</a:t>
+            </a:r>
+          </a:p>
+          <a:p>
+            <a:r>
+              <a:rPr lang="en-GB" sz="1000" i="1">
+                <a:solidFill>
+                  <a:srgbClr val="49DEB6"/>
+                </a:solidFill>
+              </a:rPr>
+              <a:t>— Forrester Research 2024</a:t>
+            </a:r>
+          </a:p>
+        </p:txBody>
+      </p:sp>
     </p:spTree>
   </p:cSld>
   <p:clrMapOvr>
@@ -31495,62 +31568,44 @@
           <a:lstStyle/>
           <a:p>
             <a:r>
-              <a:rPr lang="en-GB" b="1"/>
+              <a:rPr lang="en-GB" b="1" sz="1400"/>
               <a:t>TIER 1 — DETERMINISTIC</a:t>
             </a:r>
           </a:p>
           <a:p>
             <a:r>
-              <a:rPr lang="en-GB"/>
-              <a:t/>
-            </a:r>
-          </a:p>
-          <a:p>
-            <a:r>
-              <a:rPr lang="en-GB"/>
+              <a:rPr lang="en-GB" sz="1200"/>
               <a:t>Confidence: 1.0 → Auto-Merge</a:t>
             </a:r>
           </a:p>
           <a:p>
             <a:r>
-              <a:rPr lang="en-GB"/>
-              <a:t/>
-            </a:r>
-          </a:p>
-          <a:p>
-            <a:r>
-              <a:rPr lang="en-GB"/>
+              <a:rPr lang="en-GB" sz="1100"/>
               <a:t>● Exact email match</a:t>
             </a:r>
           </a:p>
           <a:p>
             <a:r>
-              <a:rPr lang="en-GB"/>
+              <a:rPr lang="en-GB" sz="1100"/>
               <a:t>● Exact phone match</a:t>
             </a:r>
           </a:p>
           <a:p>
             <a:r>
-              <a:rPr lang="en-GB"/>
-              <a:t>● CRM / external ID</a:t>
-            </a:r>
-          </a:p>
-          <a:p>
-            <a:r>
-              <a:rPr lang="en-GB"/>
+              <a:rPr lang="en-GB" sz="1100"/>
+              <a:t>● CRM / external ID match</a:t>
+            </a:r>
+          </a:p>
+          <a:p>
+            <a:r>
+              <a:rPr lang="en-GB" sz="1100"/>
               <a:t>● Device ID exact match</a:t>
             </a:r>
           </a:p>
           <a:p>
             <a:r>
-              <a:rPr lang="en-GB"/>
-              <a:t/>
-            </a:r>
-          </a:p>
-          <a:p>
-            <a:r>
-              <a:rPr lang="en-GB"/>
-              <a:t>Result: Profiles merged immediately. CDH receives unified profile.</a:t>
+              <a:rPr lang="en-GB" sz="1100" i="1"/>
+              <a:t>Result: Auto-merged immediately</a:t>
             </a:r>
           </a:p>
         </p:txBody>
@@ -31593,62 +31648,44 @@
           <a:lstStyle/>
           <a:p>
             <a:r>
-              <a:rPr lang="en-GB" b="1"/>
+              <a:rPr lang="en-GB" b="1" sz="1400"/>
               <a:t>TIER 2 — PROBABILISTIC</a:t>
             </a:r>
           </a:p>
           <a:p>
             <a:r>
-              <a:rPr lang="en-GB"/>
-              <a:t/>
-            </a:r>
-          </a:p>
-          <a:p>
-            <a:r>
-              <a:rPr lang="en-GB"/>
+              <a:rPr lang="en-GB" sz="1200"/>
               <a:t>Confidence: 0.75–0.94 → Review Queue</a:t>
             </a:r>
           </a:p>
           <a:p>
             <a:r>
-              <a:rPr lang="en-GB"/>
-              <a:t/>
-            </a:r>
-          </a:p>
-          <a:p>
-            <a:r>
-              <a:rPr lang="en-GB"/>
+              <a:rPr lang="en-GB" sz="1100"/>
               <a:t>● Name + date of birth + postcode</a:t>
             </a:r>
           </a:p>
           <a:p>
             <a:r>
-              <a:rPr lang="en-GB"/>
-              <a:t>● Browser fingerprint</a:t>
-            </a:r>
-          </a:p>
-          <a:p>
-            <a:r>
-              <a:rPr lang="en-GB"/>
-              <a:t>● Jaro-Winkler fuzzy name match</a:t>
-            </a:r>
-          </a:p>
-          <a:p>
-            <a:r>
-              <a:rPr lang="en-GB"/>
+              <a:rPr lang="en-GB" sz="1100"/>
+              <a:t>● Browser fingerprint match</a:t>
+            </a:r>
+          </a:p>
+          <a:p>
+            <a:r>
+              <a:rPr lang="en-GB" sz="1100"/>
+              <a:t>● Jaro-Winkler fuzzy name</a:t>
+            </a:r>
+          </a:p>
+          <a:p>
+            <a:r>
+              <a:rPr lang="en-GB" sz="1100"/>
               <a:t>● Multi-signal composite score</a:t>
             </a:r>
           </a:p>
           <a:p>
             <a:r>
-              <a:rPr lang="en-GB"/>
-              <a:t/>
-            </a:r>
-          </a:p>
-          <a:p>
-            <a:r>
-              <a:rPr lang="en-GB"/>
-              <a:t>Result: Queued for human approval before merge.</a:t>
+              <a:rPr lang="en-GB" sz="1100" i="1"/>
+              <a:t>Result: Human review before merge</a:t>
             </a:r>
           </a:p>
         </p:txBody>
@@ -31691,61 +31728,43 @@
           <a:lstStyle/>
           <a:p>
             <a:r>
-              <a:rPr lang="en-GB" b="1"/>
+              <a:rPr lang="en-GB" b="1" sz="1400"/>
               <a:t>TIER 3 — ANONYMOUS STITCH</a:t>
             </a:r>
           </a:p>
           <a:p>
             <a:r>
-              <a:rPr lang="en-GB"/>
-              <a:t/>
-            </a:r>
-          </a:p>
-          <a:p>
-            <a:r>
-              <a:rPr lang="en-GB"/>
+              <a:rPr lang="en-GB" sz="1200"/>
               <a:t>On login event → Instant</a:t>
             </a:r>
           </a:p>
           <a:p>
             <a:r>
-              <a:rPr lang="en-GB"/>
-              <a:t/>
-            </a:r>
-          </a:p>
-          <a:p>
-            <a:r>
-              <a:rPr lang="en-GB"/>
+              <a:rPr lang="en-GB" sz="1100"/>
               <a:t>● Visitor browses with cookieId</a:t>
             </a:r>
           </a:p>
           <a:p>
             <a:r>
-              <a:rPr lang="en-GB"/>
-              <a:t>● Login fires with cookieId + customerId</a:t>
-            </a:r>
-          </a:p>
-          <a:p>
-            <a:r>
-              <a:rPr lang="en-GB"/>
-              <a:t>● All pre-login events merge to known profile</a:t>
-            </a:r>
-          </a:p>
-          <a:p>
-            <a:r>
-              <a:rPr lang="en-GB"/>
-              <a:t>● CDH gets full customer journey</a:t>
-            </a:r>
-          </a:p>
-          <a:p>
-            <a:r>
-              <a:rPr lang="en-GB"/>
-              <a:t/>
-            </a:r>
-          </a:p>
-          <a:p>
-            <a:r>
-              <a:rPr lang="en-GB" b="1"/>
+              <a:rPr lang="en-GB" sz="1100"/>
+              <a:t>● Login fires both identifiers</a:t>
+            </a:r>
+          </a:p>
+          <a:p>
+            <a:r>
+              <a:rPr lang="en-GB" sz="1100"/>
+              <a:t>● Pre-login events stitch to profile</a:t>
+            </a:r>
+          </a:p>
+          <a:p>
+            <a:r>
+              <a:rPr lang="en-GB" sz="1100"/>
+              <a:t>● CDH gets full journey context</a:t>
+            </a:r>
+          </a:p>
+          <a:p>
+            <a:r>
+              <a:rPr lang="en-GB" sz="1100" b="1"/>
               <a:t>94.2% match rate in production</a:t>
             </a:r>
           </a:p>

</xml_diff>